<commit_message>
Kit 5: two owner re-audit fixes on the deck
- Slide 23 title narrowed to the chip-safe width (was running under the
  Rivera tracker chip)
- Slide 20: Rivera's filled AI Box now carries her per-part lane calls
  from step 1 (Research 3 / Outline 2 / Final draft 1) instead of the old
  single-lane exemplar; steps 1 and 2 no longer contradict each other,
  and her Okay/Not-okay lines match the parts

Deck rebuilt; slides 20 and 23 re-verified in the LibreOffice render.

Co-Authored-By: Claude Fable 5 <noreply@anthropic.com>
Claude-Session: https://claude.ai/code/session_019agQ42s1igQaB2X7GGat9R
</commit_message>
<xml_diff>
--- a/kits/kit05/Kit05_PresentationDeck.pptx
+++ b/kits/kit05/Kit05_PresentationDeck.pptx
@@ -13161,7 +13161,7 @@
                 <a:ea typeface="Inter" pitchFamily="34" charset="-122"/>
                 <a:cs typeface="Inter" pitchFamily="34" charset="-120"/>
               </a:rPr>
-              <a:t>☒ 2 · AI-assisted, because I'm grading your argument, not your typing.
+              <a:t>by part · Research ☒ 3 · Outline ☒ 2 · Final draft ☒ 1, because I'm grading your argument, not your typing.
 </a:t>
             </a:r>
             <a:pPr indent="0" marL="0">
@@ -13196,7 +13196,7 @@
                 <a:ea typeface="Inter" pitchFamily="34" charset="-122"/>
                 <a:cs typeface="Inter" pitchFamily="34" charset="-120"/>
               </a:rPr>
-              <a:t>brainstorming ideas; feedback on your draft.
+              <a:t>AI to compare sources; brainstorming and feedback on your outline.
 </a:t>
             </a:r>
             <a:pPr indent="0" marL="0">
@@ -13231,7 +13231,7 @@
                 <a:ea typeface="Inter" pitchFamily="34" charset="-122"/>
                 <a:cs typeface="Inter" pitchFamily="34" charset="-120"/>
               </a:rPr>
-              <a:t>turning in sentences you didn't write.
+              <a:t>AI-written sentences in your final draft.
 </a:t>
             </a:r>
             <a:pPr indent="0" marL="0">
@@ -15151,23 +15151,23 @@
         <p:spPr>
           <a:xfrm>
             <a:off x="548640" y="384048"/>
-            <a:ext cx="11091672" cy="777240"/>
-          </a:xfrm>
-          <a:prstGeom prst="rect">
-            <a:avLst/>
-          </a:prstGeom>
-          <a:noFill/>
-          <a:ln/>
-        </p:spPr>
-        <p:txBody>
-          <a:bodyPr wrap="square" lIns="0" tIns="0" rIns="0" bIns="0" rtlCol="0" anchor="ctr"/>
-          <a:lstStyle/>
-          <a:p>
-            <a:pPr indent="0" marL="0">
-              <a:buNone/>
-            </a:pPr>
-            <a:r>
-              <a:rPr lang="en-US" sz="3200" b="1" dirty="0">
+            <a:ext cx="7955280" cy="777240"/>
+          </a:xfrm>
+          <a:prstGeom prst="rect">
+            <a:avLst/>
+          </a:prstGeom>
+          <a:noFill/>
+          <a:ln/>
+        </p:spPr>
+        <p:txBody>
+          <a:bodyPr wrap="square" lIns="0" tIns="0" rIns="0" bIns="0" rtlCol="0" anchor="ctr"/>
+          <a:lstStyle/>
+          <a:p>
+            <a:pPr indent="0" marL="0">
+              <a:buNone/>
+            </a:pPr>
+            <a:r>
+              <a:rPr lang="en-US" sz="2800" b="1" dirty="0">
                 <a:solidFill>
                   <a:srgbClr val="13293D"/>
                 </a:solidFill>
@@ -15177,7 +15177,7 @@
               </a:rPr>
               <a:t>Read us your AI Box, or your sentences</a:t>
             </a:r>
-            <a:endParaRPr lang="en-US" sz="3200" dirty="0"/>
+            <a:endParaRPr lang="en-US" sz="2800" dirty="0"/>
           </a:p>
         </p:txBody>
       </p:sp>

</xml_diff>